<commit_message>
docs: README, runbook e PPT atualizados para PostgreSQL no Supabase
- docs/deploy-render-azure.md vira docs/deploy-render-supabase.md
  (projeto, schemas e usuários por ambiente, Session pooler, Render)
- README e lista de evidências sem referências a SQL Server/Azure
- PPT: arquitetura com Supabase e desafios reais (Azure for Students
  indisponível, limite de projetos Free, cold start)

Co-Authored-By: Claude Opus 5.5 <noreply@anthropic.com>
</commit_message>
<xml_diff>
--- a/docs/Documentacao_DevOps.pptx
+++ b/docs/Documentacao_DevOps.pptx
@@ -4954,7 +4954,7 @@
       </p:sp>
       <p:sp>
         <p:nvSpPr>
-          <p:cNvPr id="6" name="Espaço para 14-azure-sql.png"/>
+          <p:cNvPr id="6" name="Espaço para 14-supabase.png"/>
           <p:cNvSpPr/>
           <p:nvPr/>
         </p:nvSpPr>
@@ -5025,7 +5025,7 @@
                 </a:solidFill>
                 <a:latin typeface="Courier New"/>
               </a:rPr>
-              <a:t>14-azure-sql.png</a:t>
+              <a:t>14-supabase.png</a:t>
             </a:r>
           </a:p>
         </p:txBody>
@@ -5062,7 +5062,7 @@
                 </a:solidFill>
                 <a:latin typeface="Arial"/>
               </a:rPr>
-              <a:t>Azure SQL: bancos de staging e produção (free offer)</a:t>
+              <a:t>Supabase: schemas de staging e produção (plano Free)</a:t>
             </a:r>
           </a:p>
         </p:txBody>
@@ -5873,7 +5873,7 @@
                           </a:solidFill>
                           <a:latin typeface="Arial"/>
                         </a:rPr>
-                        <a:t>Healthcheck do banco quebrado: o sqlcmd mudou para mssql-tools18 e exige -C</a:t>
+                        <a:t>O Azure for Students não pôde ser ativado, e o SQL Server (2 GB, x86) não tem hospedagem gratuita fora dele</a:t>
                       </a:r>
                     </a:p>
                   </a:txBody>
@@ -5900,7 +5900,7 @@
                           </a:solidFill>
                           <a:latin typeface="Arial"/>
                         </a:rPr>
-                        <a:t>Caminho novo com -C e depends_on com condition: service_healthy</a:t>
+                        <a:t>Troca para PostgreSQL: provider Npgsql, migration regerada, compose com postgres:17 e banco no Supabase Free</a:t>
                       </a:r>
                     </a:p>
                   </a:txBody>
@@ -5985,7 +5985,7 @@
                           </a:solidFill>
                           <a:latin typeface="Arial"/>
                         </a:rPr>
-                        <a:t>Mac Apple Silicon sem Docker e SQL Server só x86</a:t>
+                        <a:t>Mac sem Docker instalado para testar o compose</a:t>
                       </a:r>
                     </a:p>
                   </a:txBody>
@@ -6012,7 +6012,7 @@
                           </a:solidFill>
                           <a:latin typeface="Arial"/>
                         </a:rPr>
-                        <a:t>Compose validado no runner x86 do GitHub Actions em todo PR (job compose-smoke)</a:t>
+                        <a:t>Compose validado no runner do GitHub Actions em todo PR (job compose-smoke)</a:t>
                       </a:r>
                     </a:p>
                   </a:txBody>
@@ -6041,7 +6041,7 @@
                           </a:solidFill>
                           <a:latin typeface="Arial"/>
                         </a:rPr>
-                        <a:t>Hospedar SQL Server (mínimo 2 GB, x86) sem custo</a:t>
+                        <a:t>Plano Free do Supabase permite só 2 projetos ativos</a:t>
                       </a:r>
                     </a:p>
                   </a:txBody>
@@ -6068,7 +6068,7 @@
                           </a:solidFill>
                           <a:latin typeface="Arial"/>
                         </a:rPr>
-                        <a:t>Render Free para a API + Azure SQL free offer: mesmo motor, sem trocar de banco</a:t>
+                        <a:t>Um projeto com schemas staging e production, cada um com usuário próprio e senha em hash SCRAM</a:t>
                       </a:r>
                     </a:p>
                   </a:txBody>
@@ -6097,7 +6097,7 @@
                           </a:solidFill>
                           <a:latin typeface="Arial"/>
                         </a:rPr>
-                        <a:t>Cold start: o Render dorme e o Azure SQL pausa</a:t>
+                        <a:t>Cold start: o Render dorme e o Supabase pausa após 7 dias sem uso</a:t>
                       </a:r>
                     </a:p>
                   </a:txBody>
@@ -6124,7 +6124,7 @@
                           </a:solidFill>
                           <a:latin typeface="Arial"/>
                         </a:rPr>
-                        <a:t>EnableRetryOnFailure e smoke test com retry até o /health responder a versão do commit</a:t>
+                        <a:t>Retry no EF, smoke test com retry e health check diário agendado no GitHub Actions</a:t>
                       </a:r>
                     </a:p>
                   </a:txBody>
@@ -7045,7 +7045,7 @@
                           </a:solidFill>
                           <a:latin typeface="Arial"/>
                         </a:rPr>
-                        <a:t>Render + Azure SQL</a:t>
+                        <a:t>Render + Supabase</a:t>
                       </a:r>
                     </a:p>
                   </a:txBody>
@@ -7909,7 +7909,7 @@
                 </a:solidFill>
                 <a:latin typeface="Arial"/>
               </a:rPr>
-              <a:t>EF Core 8 com SQL Server, autenticação JWT e Swagger</a:t>
+              <a:t>EF Core 8 com PostgreSQL (Supabase), autenticação JWT e Swagger</a:t>
             </a:r>
           </a:p>
           <a:p>
@@ -9827,7 +9827,7 @@
                 </a:solidFill>
                 <a:latin typeface="Arial"/>
               </a:rPr>
-              <a:t>Render + Azure SQL Database</a:t>
+              <a:t>Render + Supabase (PostgreSQL)</a:t>
             </a:r>
           </a:p>
         </p:txBody>
@@ -10267,7 +10267,7 @@
                           </a:solidFill>
                           <a:latin typeface="Arial"/>
                         </a:rPr>
-                        <a:t>Valida os 3 arquivos compose, sobe API + SQL Server 2022 e testa health, swagger, register, login e admin</a:t>
+                        <a:t>Valida os 3 arquivos compose, sobe API + PostgreSQL 17 e testa health, swagger, register, login e admin</a:t>
                       </a:r>
                     </a:p>
                   </a:txBody>
@@ -11095,7 +11095,7 @@
                 </a:solidFill>
                 <a:latin typeface="Arial"/>
               </a:rPr>
-              <a:t>SQL Server 2022</a:t>
+              <a:t>PostgreSQL 17</a:t>
             </a:r>
           </a:p>
           <a:p>
@@ -11111,7 +11111,7 @@
                 </a:solidFill>
                 <a:latin typeface="Arial"/>
               </a:rPr>
-              <a:t>healthcheck sqlcmd</a:t>
+              <a:t>healthcheck pg_isready</a:t>
             </a:r>
           </a:p>
           <a:p>
@@ -11127,7 +11127,7 @@
                 </a:solidFill>
                 <a:latin typeface="Arial"/>
               </a:rPr>
-              <a:t>(mssql-tools18 -C)</a:t>
+              <a:t>porta só em 127.0.0.1</a:t>
             </a:r>
           </a:p>
         </p:txBody>
@@ -11358,7 +11358,7 @@
       </p:cxnSp>
       <p:sp>
         <p:nvSpPr>
-          <p:cNvPr id="14" name="Volume mssql-data"/>
+          <p:cNvPr id="14" name="Volume pg-data"/>
           <p:cNvSpPr/>
           <p:nvPr/>
         </p:nvSpPr>
@@ -11410,8 +11410,8 @@
         </p:nvSpPr>
         <p:spPr>
           <a:xfrm>
-            <a:off x="3840480" y="4681728"/>
-            <a:ext cx="1691640" cy="731520"/>
+            <a:off x="3703320" y="4681728"/>
+            <a:ext cx="1965960" cy="731520"/>
           </a:xfrm>
           <a:prstGeom prst="rect">
             <a:avLst/>
@@ -11434,7 +11434,7 @@
                 </a:solidFill>
                 <a:latin typeface="Arial"/>
               </a:rPr>
-              <a:t>mssql-data</a:t>
+              <a:t>pg-data</a:t>
             </a:r>
           </a:p>
           <a:p>
@@ -11450,7 +11450,7 @@
                 </a:solidFill>
                 <a:latin typeface="Arial"/>
               </a:rPr>
-              <a:t>/var/opt/mssql</a:t>
+              <a:t>/var/lib/postgresql</a:t>
             </a:r>
           </a:p>
         </p:txBody>
@@ -11748,7 +11748,7 @@
                 </a:solidFill>
                 <a:latin typeface="Arial"/>
               </a:rPr>
-              <a:t>Azure SQL</a:t>
+              <a:t>Supabase</a:t>
             </a:r>
           </a:p>
           <a:p>
@@ -11764,7 +11764,7 @@
                 </a:solidFill>
                 <a:latin typeface="Arial"/>
               </a:rPr>
-              <a:t>orbitalsos-staging</a:t>
+              <a:t>schema staging</a:t>
             </a:r>
           </a:p>
           <a:p>
@@ -11780,7 +11780,7 @@
                 </a:solidFill>
                 <a:latin typeface="Arial"/>
               </a:rPr>
-              <a:t>free offer (serverless)</a:t>
+              <a:t>usuário orbital_staging</a:t>
             </a:r>
           </a:p>
         </p:txBody>
@@ -12002,7 +12002,7 @@
                 </a:solidFill>
                 <a:latin typeface="Arial"/>
               </a:rPr>
-              <a:t>Azure SQL</a:t>
+              <a:t>Supabase</a:t>
             </a:r>
           </a:p>
           <a:p>
@@ -12018,7 +12018,7 @@
                 </a:solidFill>
                 <a:latin typeface="Arial"/>
               </a:rPr>
-              <a:t>orbitalsos-prod</a:t>
+              <a:t>schema production</a:t>
             </a:r>
           </a:p>
           <a:p>
@@ -12034,7 +12034,7 @@
                 </a:solidFill>
                 <a:latin typeface="Arial"/>
               </a:rPr>
-              <a:t>free offer (serverless)</a:t>
+              <a:t>usuário orbital_prod</a:t>
             </a:r>
           </a:p>
         </p:txBody>

</xml_diff>

<commit_message>
docs: ambientes no ar no Render + Supabase e checklist de deploy
Co-Authored-By: Claude Opus 5.5 <noreply@anthropic.com>
</commit_message>
<xml_diff>
--- a/docs/Documentacao_DevOps.pptx
+++ b/docs/Documentacao_DevOps.pptx
@@ -7014,11 +7014,11 @@
                       <a:r>
                         <a:rPr sz="1400" b="1" i="0">
                           <a:solidFill>
-                            <a:srgbClr val="E8572A"/>
+                            <a:srgbClr val="2E7D4F"/>
                           </a:solidFill>
                           <a:latin typeface="Arial"/>
                         </a:rPr>
-                        <a:t>Pendente</a:t>
+                        <a:t>Concluído</a:t>
                       </a:r>
                     </a:p>
                   </a:txBody>

</xml_diff>

<commit_message>
docs: prints de evidência (pipeline, GHCR, environments, staging, produção e Render)
Co-Authored-By: Claude Opus 5.5 <noreply@anthropic.com>
</commit_message>
<xml_diff>
--- a/docs/Documentacao_DevOps.pptx
+++ b/docs/Documentacao_DevOps.pptx
@@ -3625,84 +3625,35 @@
           </a:p>
         </p:txBody>
       </p:sp>
-      <p:sp>
-        <p:nvSpPr>
-          <p:cNvPr id="4" name="Espaço para 06-aprovacao-producao.png"/>
-          <p:cNvSpPr/>
-          <p:nvPr/>
-        </p:nvSpPr>
-        <p:spPr>
-          <a:xfrm>
-            <a:off x="548640" y="1463040"/>
-            <a:ext cx="5394960" cy="4297680"/>
-          </a:xfrm>
-          <a:prstGeom prst="roundRect">
-            <a:avLst>
-              <a:gd name="adj" fmla="val 2127"/>
-            </a:avLst>
-          </a:prstGeom>
-          <a:solidFill>
-            <a:srgbClr val="F5F8F8"/>
-          </a:solidFill>
-          <a:ln w="15875">
+      <p:pic>
+        <p:nvPicPr>
+          <p:cNvPr id="4" name="Picture 3" descr="06-aprovacao-producao.png"/>
+          <p:cNvPicPr>
+            <a:picLocks noChangeAspect="1"/>
+          </p:cNvPicPr>
+          <p:nvPr/>
+        </p:nvPicPr>
+        <p:blipFill>
+          <a:blip r:embed="rId2"/>
+          <a:stretch>
+            <a:fillRect/>
+          </a:stretch>
+        </p:blipFill>
+        <p:spPr>
+          <a:xfrm>
+            <a:off x="548640" y="1976532"/>
+            <a:ext cx="5394960" cy="3270694"/>
+          </a:xfrm>
+          <a:prstGeom prst="rect">
+            <a:avLst/>
+          </a:prstGeom>
+          <a:ln w="9525">
             <a:solidFill>
-              <a:srgbClr val="9AAEB1"/>
+              <a:srgbClr val="C9D9D6"/>
             </a:solidFill>
-            <a:prstDash val="dash"/>
           </a:ln>
-          <a:effectLst/>
-        </p:spPr>
-        <p:style>
-          <a:lnRef idx="1">
-            <a:schemeClr val="accent1"/>
-          </a:lnRef>
-          <a:fillRef idx="3">
-            <a:schemeClr val="accent1"/>
-          </a:fillRef>
-          <a:effectRef idx="2">
-            <a:schemeClr val="accent1"/>
-          </a:effectRef>
-          <a:fontRef idx="minor">
-            <a:schemeClr val="lt1"/>
-          </a:fontRef>
-        </p:style>
-        <p:txBody>
-          <a:bodyPr rtlCol="0" anchor="ctr" wrap="square"/>
-          <a:lstStyle/>
-          <a:p>
-            <a:pPr algn="ctr">
-              <a:spcAft>
-                <a:spcPts val="400"/>
-              </a:spcAft>
-            </a:pPr>
-            <a:r>
-              <a:rPr sz="1600" b="1" i="0">
-                <a:solidFill>
-                  <a:srgbClr val="56686C"/>
-                </a:solidFill>
-                <a:latin typeface="Arial"/>
-              </a:rPr>
-              <a:t>Cole aqui o print</a:t>
-            </a:r>
-          </a:p>
-          <a:p>
-            <a:pPr algn="ctr">
-              <a:spcAft>
-                <a:spcPts val="400"/>
-              </a:spcAft>
-            </a:pPr>
-            <a:r>
-              <a:rPr sz="1400" b="0" i="0">
-                <a:solidFill>
-                  <a:srgbClr val="E8572A"/>
-                </a:solidFill>
-                <a:latin typeface="Courier New"/>
-              </a:rPr>
-              <a:t>06-aprovacao-producao.png</a:t>
-            </a:r>
-          </a:p>
-        </p:txBody>
-      </p:sp>
+        </p:spPr>
+      </p:pic>
       <p:sp>
         <p:nvSpPr>
           <p:cNvPr id="5" name="TextBox 4"/>
@@ -3740,84 +3691,35 @@
           </a:p>
         </p:txBody>
       </p:sp>
-      <p:sp>
-        <p:nvSpPr>
-          <p:cNvPr id="6" name="Espaço para 08-environments.png"/>
-          <p:cNvSpPr/>
-          <p:nvPr/>
-        </p:nvSpPr>
-        <p:spPr>
-          <a:xfrm>
-            <a:off x="6217920" y="1463040"/>
-            <a:ext cx="5394960" cy="4297680"/>
-          </a:xfrm>
-          <a:prstGeom prst="roundRect">
-            <a:avLst>
-              <a:gd name="adj" fmla="val 2127"/>
-            </a:avLst>
-          </a:prstGeom>
-          <a:solidFill>
-            <a:srgbClr val="F5F8F8"/>
-          </a:solidFill>
-          <a:ln w="15875">
+      <p:pic>
+        <p:nvPicPr>
+          <p:cNvPr id="6" name="Picture 5" descr="08-environments.png"/>
+          <p:cNvPicPr>
+            <a:picLocks noChangeAspect="1"/>
+          </p:cNvPicPr>
+          <p:nvPr/>
+        </p:nvPicPr>
+        <p:blipFill>
+          <a:blip r:embed="rId3"/>
+          <a:stretch>
+            <a:fillRect/>
+          </a:stretch>
+        </p:blipFill>
+        <p:spPr>
+          <a:xfrm>
+            <a:off x="6217920" y="1976876"/>
+            <a:ext cx="5394960" cy="3270006"/>
+          </a:xfrm>
+          <a:prstGeom prst="rect">
+            <a:avLst/>
+          </a:prstGeom>
+          <a:ln w="9525">
             <a:solidFill>
-              <a:srgbClr val="9AAEB1"/>
+              <a:srgbClr val="C9D9D6"/>
             </a:solidFill>
-            <a:prstDash val="dash"/>
           </a:ln>
-          <a:effectLst/>
-        </p:spPr>
-        <p:style>
-          <a:lnRef idx="1">
-            <a:schemeClr val="accent1"/>
-          </a:lnRef>
-          <a:fillRef idx="3">
-            <a:schemeClr val="accent1"/>
-          </a:fillRef>
-          <a:effectRef idx="2">
-            <a:schemeClr val="accent1"/>
-          </a:effectRef>
-          <a:fontRef idx="minor">
-            <a:schemeClr val="lt1"/>
-          </a:fontRef>
-        </p:style>
-        <p:txBody>
-          <a:bodyPr rtlCol="0" anchor="ctr" wrap="square"/>
-          <a:lstStyle/>
-          <a:p>
-            <a:pPr algn="ctr">
-              <a:spcAft>
-                <a:spcPts val="400"/>
-              </a:spcAft>
-            </a:pPr>
-            <a:r>
-              <a:rPr sz="1600" b="1" i="0">
-                <a:solidFill>
-                  <a:srgbClr val="56686C"/>
-                </a:solidFill>
-                <a:latin typeface="Arial"/>
-              </a:rPr>
-              <a:t>Cole aqui o print</a:t>
-            </a:r>
-          </a:p>
-          <a:p>
-            <a:pPr algn="ctr">
-              <a:spcAft>
-                <a:spcPts val="400"/>
-              </a:spcAft>
-            </a:pPr>
-            <a:r>
-              <a:rPr sz="1400" b="0" i="0">
-                <a:solidFill>
-                  <a:srgbClr val="E8572A"/>
-                </a:solidFill>
-                <a:latin typeface="Courier New"/>
-              </a:rPr>
-              <a:t>08-environments.png</a:t>
-            </a:r>
-          </a:p>
-        </p:txBody>
-      </p:sp>
+        </p:spPr>
+      </p:pic>
       <p:sp>
         <p:nvSpPr>
           <p:cNvPr id="7" name="TextBox 6"/>
@@ -4029,84 +3931,35 @@
           </a:p>
         </p:txBody>
       </p:sp>
-      <p:sp>
-        <p:nvSpPr>
-          <p:cNvPr id="4" name="Espaço para 09-staging-health.png"/>
-          <p:cNvSpPr/>
-          <p:nvPr/>
-        </p:nvSpPr>
-        <p:spPr>
-          <a:xfrm>
-            <a:off x="548640" y="1463040"/>
-            <a:ext cx="5394960" cy="4297680"/>
-          </a:xfrm>
-          <a:prstGeom prst="roundRect">
-            <a:avLst>
-              <a:gd name="adj" fmla="val 2127"/>
-            </a:avLst>
-          </a:prstGeom>
-          <a:solidFill>
-            <a:srgbClr val="F5F8F8"/>
-          </a:solidFill>
-          <a:ln w="15875">
+      <p:pic>
+        <p:nvPicPr>
+          <p:cNvPr id="4" name="Picture 3" descr="09-staging-health.png"/>
+          <p:cNvPicPr>
+            <a:picLocks noChangeAspect="1"/>
+          </p:cNvPicPr>
+          <p:nvPr/>
+        </p:nvPicPr>
+        <p:blipFill>
+          <a:blip r:embed="rId2"/>
+          <a:stretch>
+            <a:fillRect/>
+          </a:stretch>
+        </p:blipFill>
+        <p:spPr>
+          <a:xfrm>
+            <a:off x="548640" y="2030482"/>
+            <a:ext cx="5394960" cy="3162795"/>
+          </a:xfrm>
+          <a:prstGeom prst="rect">
+            <a:avLst/>
+          </a:prstGeom>
+          <a:ln w="9525">
             <a:solidFill>
-              <a:srgbClr val="9AAEB1"/>
+              <a:srgbClr val="C9D9D6"/>
             </a:solidFill>
-            <a:prstDash val="dash"/>
           </a:ln>
-          <a:effectLst/>
-        </p:spPr>
-        <p:style>
-          <a:lnRef idx="1">
-            <a:schemeClr val="accent1"/>
-          </a:lnRef>
-          <a:fillRef idx="3">
-            <a:schemeClr val="accent1"/>
-          </a:fillRef>
-          <a:effectRef idx="2">
-            <a:schemeClr val="accent1"/>
-          </a:effectRef>
-          <a:fontRef idx="minor">
-            <a:schemeClr val="lt1"/>
-          </a:fontRef>
-        </p:style>
-        <p:txBody>
-          <a:bodyPr rtlCol="0" anchor="ctr" wrap="square"/>
-          <a:lstStyle/>
-          <a:p>
-            <a:pPr algn="ctr">
-              <a:spcAft>
-                <a:spcPts val="400"/>
-              </a:spcAft>
-            </a:pPr>
-            <a:r>
-              <a:rPr sz="1600" b="1" i="0">
-                <a:solidFill>
-                  <a:srgbClr val="56686C"/>
-                </a:solidFill>
-                <a:latin typeface="Arial"/>
-              </a:rPr>
-              <a:t>Cole aqui o print</a:t>
-            </a:r>
-          </a:p>
-          <a:p>
-            <a:pPr algn="ctr">
-              <a:spcAft>
-                <a:spcPts val="400"/>
-              </a:spcAft>
-            </a:pPr>
-            <a:r>
-              <a:rPr sz="1400" b="0" i="0">
-                <a:solidFill>
-                  <a:srgbClr val="E8572A"/>
-                </a:solidFill>
-                <a:latin typeface="Courier New"/>
-              </a:rPr>
-              <a:t>09-staging-health.png</a:t>
-            </a:r>
-          </a:p>
-        </p:txBody>
-      </p:sp>
+        </p:spPr>
+      </p:pic>
       <p:sp>
         <p:nvSpPr>
           <p:cNvPr id="5" name="TextBox 4"/>
@@ -4144,84 +3997,35 @@
           </a:p>
         </p:txBody>
       </p:sp>
-      <p:sp>
-        <p:nvSpPr>
-          <p:cNvPr id="6" name="Espaço para 10-staging-swagger.png"/>
-          <p:cNvSpPr/>
-          <p:nvPr/>
-        </p:nvSpPr>
-        <p:spPr>
-          <a:xfrm>
-            <a:off x="6217920" y="1463040"/>
-            <a:ext cx="5394960" cy="4297680"/>
-          </a:xfrm>
-          <a:prstGeom prst="roundRect">
-            <a:avLst>
-              <a:gd name="adj" fmla="val 2127"/>
-            </a:avLst>
-          </a:prstGeom>
-          <a:solidFill>
-            <a:srgbClr val="F5F8F8"/>
-          </a:solidFill>
-          <a:ln w="15875">
+      <p:pic>
+        <p:nvPicPr>
+          <p:cNvPr id="6" name="Picture 5" descr="10-staging-swagger.png"/>
+          <p:cNvPicPr>
+            <a:picLocks noChangeAspect="1"/>
+          </p:cNvPicPr>
+          <p:nvPr/>
+        </p:nvPicPr>
+        <p:blipFill>
+          <a:blip r:embed="rId3"/>
+          <a:stretch>
+            <a:fillRect/>
+          </a:stretch>
+        </p:blipFill>
+        <p:spPr>
+          <a:xfrm>
+            <a:off x="6217920" y="1811312"/>
+            <a:ext cx="5394960" cy="3601135"/>
+          </a:xfrm>
+          <a:prstGeom prst="rect">
+            <a:avLst/>
+          </a:prstGeom>
+          <a:ln w="9525">
             <a:solidFill>
-              <a:srgbClr val="9AAEB1"/>
+              <a:srgbClr val="C9D9D6"/>
             </a:solidFill>
-            <a:prstDash val="dash"/>
           </a:ln>
-          <a:effectLst/>
-        </p:spPr>
-        <p:style>
-          <a:lnRef idx="1">
-            <a:schemeClr val="accent1"/>
-          </a:lnRef>
-          <a:fillRef idx="3">
-            <a:schemeClr val="accent1"/>
-          </a:fillRef>
-          <a:effectRef idx="2">
-            <a:schemeClr val="accent1"/>
-          </a:effectRef>
-          <a:fontRef idx="minor">
-            <a:schemeClr val="lt1"/>
-          </a:fontRef>
-        </p:style>
-        <p:txBody>
-          <a:bodyPr rtlCol="0" anchor="ctr" wrap="square"/>
-          <a:lstStyle/>
-          <a:p>
-            <a:pPr algn="ctr">
-              <a:spcAft>
-                <a:spcPts val="400"/>
-              </a:spcAft>
-            </a:pPr>
-            <a:r>
-              <a:rPr sz="1600" b="1" i="0">
-                <a:solidFill>
-                  <a:srgbClr val="56686C"/>
-                </a:solidFill>
-                <a:latin typeface="Arial"/>
-              </a:rPr>
-              <a:t>Cole aqui o print</a:t>
-            </a:r>
-          </a:p>
-          <a:p>
-            <a:pPr algn="ctr">
-              <a:spcAft>
-                <a:spcPts val="400"/>
-              </a:spcAft>
-            </a:pPr>
-            <a:r>
-              <a:rPr sz="1400" b="0" i="0">
-                <a:solidFill>
-                  <a:srgbClr val="E8572A"/>
-                </a:solidFill>
-                <a:latin typeface="Courier New"/>
-              </a:rPr>
-              <a:t>10-staging-swagger.png</a:t>
-            </a:r>
-          </a:p>
-        </p:txBody>
-      </p:sp>
+        </p:spPr>
+      </p:pic>
       <p:sp>
         <p:nvSpPr>
           <p:cNvPr id="7" name="TextBox 6"/>
@@ -4433,84 +4237,35 @@
           </a:p>
         </p:txBody>
       </p:sp>
-      <p:sp>
-        <p:nvSpPr>
-          <p:cNvPr id="4" name="Espaço para 11-producao-health.png"/>
-          <p:cNvSpPr/>
-          <p:nvPr/>
-        </p:nvSpPr>
-        <p:spPr>
-          <a:xfrm>
-            <a:off x="548640" y="1463040"/>
-            <a:ext cx="5394960" cy="4297680"/>
-          </a:xfrm>
-          <a:prstGeom prst="roundRect">
-            <a:avLst>
-              <a:gd name="adj" fmla="val 2127"/>
-            </a:avLst>
-          </a:prstGeom>
-          <a:solidFill>
-            <a:srgbClr val="F5F8F8"/>
-          </a:solidFill>
-          <a:ln w="15875">
+      <p:pic>
+        <p:nvPicPr>
+          <p:cNvPr id="4" name="Picture 3" descr="11-producao-health.png"/>
+          <p:cNvPicPr>
+            <a:picLocks noChangeAspect="1"/>
+          </p:cNvPicPr>
+          <p:nvPr/>
+        </p:nvPicPr>
+        <p:blipFill>
+          <a:blip r:embed="rId2"/>
+          <a:stretch>
+            <a:fillRect/>
+          </a:stretch>
+        </p:blipFill>
+        <p:spPr>
+          <a:xfrm>
+            <a:off x="548640" y="2030482"/>
+            <a:ext cx="5394960" cy="3162795"/>
+          </a:xfrm>
+          <a:prstGeom prst="rect">
+            <a:avLst/>
+          </a:prstGeom>
+          <a:ln w="9525">
             <a:solidFill>
-              <a:srgbClr val="9AAEB1"/>
+              <a:srgbClr val="C9D9D6"/>
             </a:solidFill>
-            <a:prstDash val="dash"/>
           </a:ln>
-          <a:effectLst/>
-        </p:spPr>
-        <p:style>
-          <a:lnRef idx="1">
-            <a:schemeClr val="accent1"/>
-          </a:lnRef>
-          <a:fillRef idx="3">
-            <a:schemeClr val="accent1"/>
-          </a:fillRef>
-          <a:effectRef idx="2">
-            <a:schemeClr val="accent1"/>
-          </a:effectRef>
-          <a:fontRef idx="minor">
-            <a:schemeClr val="lt1"/>
-          </a:fontRef>
-        </p:style>
-        <p:txBody>
-          <a:bodyPr rtlCol="0" anchor="ctr" wrap="square"/>
-          <a:lstStyle/>
-          <a:p>
-            <a:pPr algn="ctr">
-              <a:spcAft>
-                <a:spcPts val="400"/>
-              </a:spcAft>
-            </a:pPr>
-            <a:r>
-              <a:rPr sz="1600" b="1" i="0">
-                <a:solidFill>
-                  <a:srgbClr val="56686C"/>
-                </a:solidFill>
-                <a:latin typeface="Arial"/>
-              </a:rPr>
-              <a:t>Cole aqui o print</a:t>
-            </a:r>
-          </a:p>
-          <a:p>
-            <a:pPr algn="ctr">
-              <a:spcAft>
-                <a:spcPts val="400"/>
-              </a:spcAft>
-            </a:pPr>
-            <a:r>
-              <a:rPr sz="1400" b="0" i="0">
-                <a:solidFill>
-                  <a:srgbClr val="E8572A"/>
-                </a:solidFill>
-                <a:latin typeface="Courier New"/>
-              </a:rPr>
-              <a:t>11-producao-health.png</a:t>
-            </a:r>
-          </a:p>
-        </p:txBody>
-      </p:sp>
+        </p:spPr>
+      </p:pic>
       <p:sp>
         <p:nvSpPr>
           <p:cNvPr id="5" name="TextBox 4"/>
@@ -4548,84 +4303,35 @@
           </a:p>
         </p:txBody>
       </p:sp>
-      <p:sp>
-        <p:nvSpPr>
-          <p:cNvPr id="6" name="Espaço para 12-producao-swagger.png"/>
-          <p:cNvSpPr/>
-          <p:nvPr/>
-        </p:nvSpPr>
-        <p:spPr>
-          <a:xfrm>
-            <a:off x="6217920" y="1463040"/>
-            <a:ext cx="5394960" cy="4297680"/>
-          </a:xfrm>
-          <a:prstGeom prst="roundRect">
-            <a:avLst>
-              <a:gd name="adj" fmla="val 2127"/>
-            </a:avLst>
-          </a:prstGeom>
-          <a:solidFill>
-            <a:srgbClr val="F5F8F8"/>
-          </a:solidFill>
-          <a:ln w="15875">
+      <p:pic>
+        <p:nvPicPr>
+          <p:cNvPr id="6" name="Picture 5" descr="12-producao-swagger.png"/>
+          <p:cNvPicPr>
+            <a:picLocks noChangeAspect="1"/>
+          </p:cNvPicPr>
+          <p:nvPr/>
+        </p:nvPicPr>
+        <p:blipFill>
+          <a:blip r:embed="rId3"/>
+          <a:stretch>
+            <a:fillRect/>
+          </a:stretch>
+        </p:blipFill>
+        <p:spPr>
+          <a:xfrm>
+            <a:off x="6217920" y="2030482"/>
+            <a:ext cx="5394960" cy="3162795"/>
+          </a:xfrm>
+          <a:prstGeom prst="rect">
+            <a:avLst/>
+          </a:prstGeom>
+          <a:ln w="9525">
             <a:solidFill>
-              <a:srgbClr val="9AAEB1"/>
+              <a:srgbClr val="C9D9D6"/>
             </a:solidFill>
-            <a:prstDash val="dash"/>
           </a:ln>
-          <a:effectLst/>
-        </p:spPr>
-        <p:style>
-          <a:lnRef idx="1">
-            <a:schemeClr val="accent1"/>
-          </a:lnRef>
-          <a:fillRef idx="3">
-            <a:schemeClr val="accent1"/>
-          </a:fillRef>
-          <a:effectRef idx="2">
-            <a:schemeClr val="accent1"/>
-          </a:effectRef>
-          <a:fontRef idx="minor">
-            <a:schemeClr val="lt1"/>
-          </a:fontRef>
-        </p:style>
-        <p:txBody>
-          <a:bodyPr rtlCol="0" anchor="ctr" wrap="square"/>
-          <a:lstStyle/>
-          <a:p>
-            <a:pPr algn="ctr">
-              <a:spcAft>
-                <a:spcPts val="400"/>
-              </a:spcAft>
-            </a:pPr>
-            <a:r>
-              <a:rPr sz="1600" b="1" i="0">
-                <a:solidFill>
-                  <a:srgbClr val="56686C"/>
-                </a:solidFill>
-                <a:latin typeface="Arial"/>
-              </a:rPr>
-              <a:t>Cole aqui o print</a:t>
-            </a:r>
-          </a:p>
-          <a:p>
-            <a:pPr algn="ctr">
-              <a:spcAft>
-                <a:spcPts val="400"/>
-              </a:spcAft>
-            </a:pPr>
-            <a:r>
-              <a:rPr sz="1400" b="0" i="0">
-                <a:solidFill>
-                  <a:srgbClr val="E8572A"/>
-                </a:solidFill>
-                <a:latin typeface="Courier New"/>
-              </a:rPr>
-              <a:t>12-producao-swagger.png</a:t>
-            </a:r>
-          </a:p>
-        </p:txBody>
-      </p:sp>
+        </p:spPr>
+      </p:pic>
       <p:sp>
         <p:nvSpPr>
           <p:cNvPr id="7" name="TextBox 6"/>
@@ -4837,84 +4543,35 @@
           </a:p>
         </p:txBody>
       </p:sp>
-      <p:sp>
-        <p:nvSpPr>
-          <p:cNvPr id="4" name="Espaço para 13-render-servicos.png"/>
-          <p:cNvSpPr/>
-          <p:nvPr/>
-        </p:nvSpPr>
-        <p:spPr>
-          <a:xfrm>
-            <a:off x="548640" y="1463040"/>
-            <a:ext cx="5394960" cy="4297680"/>
-          </a:xfrm>
-          <a:prstGeom prst="roundRect">
-            <a:avLst>
-              <a:gd name="adj" fmla="val 2127"/>
-            </a:avLst>
-          </a:prstGeom>
-          <a:solidFill>
-            <a:srgbClr val="F5F8F8"/>
-          </a:solidFill>
-          <a:ln w="15875">
+      <p:pic>
+        <p:nvPicPr>
+          <p:cNvPr id="4" name="Picture 3" descr="13-render-servicos.png"/>
+          <p:cNvPicPr>
+            <a:picLocks noChangeAspect="1"/>
+          </p:cNvPicPr>
+          <p:nvPr/>
+        </p:nvPicPr>
+        <p:blipFill>
+          <a:blip r:embed="rId2"/>
+          <a:stretch>
+            <a:fillRect/>
+          </a:stretch>
+        </p:blipFill>
+        <p:spPr>
+          <a:xfrm>
+            <a:off x="548640" y="1976532"/>
+            <a:ext cx="5394960" cy="3270694"/>
+          </a:xfrm>
+          <a:prstGeom prst="rect">
+            <a:avLst/>
+          </a:prstGeom>
+          <a:ln w="9525">
             <a:solidFill>
-              <a:srgbClr val="9AAEB1"/>
+              <a:srgbClr val="C9D9D6"/>
             </a:solidFill>
-            <a:prstDash val="dash"/>
           </a:ln>
-          <a:effectLst/>
-        </p:spPr>
-        <p:style>
-          <a:lnRef idx="1">
-            <a:schemeClr val="accent1"/>
-          </a:lnRef>
-          <a:fillRef idx="3">
-            <a:schemeClr val="accent1"/>
-          </a:fillRef>
-          <a:effectRef idx="2">
-            <a:schemeClr val="accent1"/>
-          </a:effectRef>
-          <a:fontRef idx="minor">
-            <a:schemeClr val="lt1"/>
-          </a:fontRef>
-        </p:style>
-        <p:txBody>
-          <a:bodyPr rtlCol="0" anchor="ctr" wrap="square"/>
-          <a:lstStyle/>
-          <a:p>
-            <a:pPr algn="ctr">
-              <a:spcAft>
-                <a:spcPts val="400"/>
-              </a:spcAft>
-            </a:pPr>
-            <a:r>
-              <a:rPr sz="1600" b="1" i="0">
-                <a:solidFill>
-                  <a:srgbClr val="56686C"/>
-                </a:solidFill>
-                <a:latin typeface="Arial"/>
-              </a:rPr>
-              <a:t>Cole aqui o print</a:t>
-            </a:r>
-          </a:p>
-          <a:p>
-            <a:pPr algn="ctr">
-              <a:spcAft>
-                <a:spcPts val="400"/>
-              </a:spcAft>
-            </a:pPr>
-            <a:r>
-              <a:rPr sz="1400" b="0" i="0">
-                <a:solidFill>
-                  <a:srgbClr val="E8572A"/>
-                </a:solidFill>
-                <a:latin typeface="Courier New"/>
-              </a:rPr>
-              <a:t>13-render-servicos.png</a:t>
-            </a:r>
-          </a:p>
-        </p:txBody>
-      </p:sp>
+        </p:spPr>
+      </p:pic>
       <p:sp>
         <p:nvSpPr>
           <p:cNvPr id="5" name="TextBox 4"/>
@@ -13367,84 +13024,35 @@
           </a:p>
         </p:txBody>
       </p:sp>
-      <p:sp>
-        <p:nvSpPr>
-          <p:cNvPr id="4" name="Espaço para 01-pr-checks.png"/>
-          <p:cNvSpPr/>
-          <p:nvPr/>
-        </p:nvSpPr>
-        <p:spPr>
-          <a:xfrm>
-            <a:off x="548640" y="1463040"/>
-            <a:ext cx="5394960" cy="4297680"/>
-          </a:xfrm>
-          <a:prstGeom prst="roundRect">
-            <a:avLst>
-              <a:gd name="adj" fmla="val 2127"/>
-            </a:avLst>
-          </a:prstGeom>
-          <a:solidFill>
-            <a:srgbClr val="F5F8F8"/>
-          </a:solidFill>
-          <a:ln w="15875">
+      <p:pic>
+        <p:nvPicPr>
+          <p:cNvPr id="4" name="Picture 3" descr="01-pr-checks.png"/>
+          <p:cNvPicPr>
+            <a:picLocks noChangeAspect="1"/>
+          </p:cNvPicPr>
+          <p:nvPr/>
+        </p:nvPicPr>
+        <p:blipFill>
+          <a:blip r:embed="rId2"/>
+          <a:stretch>
+            <a:fillRect/>
+          </a:stretch>
+        </p:blipFill>
+        <p:spPr>
+          <a:xfrm>
+            <a:off x="548640" y="1976876"/>
+            <a:ext cx="5394960" cy="3270006"/>
+          </a:xfrm>
+          <a:prstGeom prst="rect">
+            <a:avLst/>
+          </a:prstGeom>
+          <a:ln w="9525">
             <a:solidFill>
-              <a:srgbClr val="9AAEB1"/>
+              <a:srgbClr val="C9D9D6"/>
             </a:solidFill>
-            <a:prstDash val="dash"/>
           </a:ln>
-          <a:effectLst/>
-        </p:spPr>
-        <p:style>
-          <a:lnRef idx="1">
-            <a:schemeClr val="accent1"/>
-          </a:lnRef>
-          <a:fillRef idx="3">
-            <a:schemeClr val="accent1"/>
-          </a:fillRef>
-          <a:effectRef idx="2">
-            <a:schemeClr val="accent1"/>
-          </a:effectRef>
-          <a:fontRef idx="minor">
-            <a:schemeClr val="lt1"/>
-          </a:fontRef>
-        </p:style>
-        <p:txBody>
-          <a:bodyPr rtlCol="0" anchor="ctr" wrap="square"/>
-          <a:lstStyle/>
-          <a:p>
-            <a:pPr algn="ctr">
-              <a:spcAft>
-                <a:spcPts val="400"/>
-              </a:spcAft>
-            </a:pPr>
-            <a:r>
-              <a:rPr sz="1600" b="1" i="0">
-                <a:solidFill>
-                  <a:srgbClr val="56686C"/>
-                </a:solidFill>
-                <a:latin typeface="Arial"/>
-              </a:rPr>
-              <a:t>Cole aqui o print</a:t>
-            </a:r>
-          </a:p>
-          <a:p>
-            <a:pPr algn="ctr">
-              <a:spcAft>
-                <a:spcPts val="400"/>
-              </a:spcAft>
-            </a:pPr>
-            <a:r>
-              <a:rPr sz="1400" b="0" i="0">
-                <a:solidFill>
-                  <a:srgbClr val="E8572A"/>
-                </a:solidFill>
-                <a:latin typeface="Courier New"/>
-              </a:rPr>
-              <a:t>01-pr-checks.png</a:t>
-            </a:r>
-          </a:p>
-        </p:txBody>
-      </p:sp>
+        </p:spPr>
+      </p:pic>
       <p:sp>
         <p:nvSpPr>
           <p:cNvPr id="5" name="TextBox 4"/>
@@ -13886,84 +13494,35 @@
           </a:p>
         </p:txBody>
       </p:sp>
-      <p:sp>
-        <p:nvSpPr>
-          <p:cNvPr id="6" name="Espaço para 05-ghcr-imagem.png"/>
-          <p:cNvSpPr/>
-          <p:nvPr/>
-        </p:nvSpPr>
-        <p:spPr>
-          <a:xfrm>
-            <a:off x="6217920" y="1463040"/>
-            <a:ext cx="5394960" cy="4297680"/>
-          </a:xfrm>
-          <a:prstGeom prst="roundRect">
-            <a:avLst>
-              <a:gd name="adj" fmla="val 2127"/>
-            </a:avLst>
-          </a:prstGeom>
-          <a:solidFill>
-            <a:srgbClr val="F5F8F8"/>
-          </a:solidFill>
-          <a:ln w="15875">
+      <p:pic>
+        <p:nvPicPr>
+          <p:cNvPr id="6" name="Picture 5" descr="05-ghcr-imagem.png"/>
+          <p:cNvPicPr>
+            <a:picLocks noChangeAspect="1"/>
+          </p:cNvPicPr>
+          <p:nvPr/>
+        </p:nvPicPr>
+        <p:blipFill>
+          <a:blip r:embed="rId2"/>
+          <a:stretch>
+            <a:fillRect/>
+          </a:stretch>
+        </p:blipFill>
+        <p:spPr>
+          <a:xfrm>
+            <a:off x="6217920" y="1976876"/>
+            <a:ext cx="5394960" cy="3270006"/>
+          </a:xfrm>
+          <a:prstGeom prst="rect">
+            <a:avLst/>
+          </a:prstGeom>
+          <a:ln w="9525">
             <a:solidFill>
-              <a:srgbClr val="9AAEB1"/>
+              <a:srgbClr val="C9D9D6"/>
             </a:solidFill>
-            <a:prstDash val="dash"/>
           </a:ln>
-          <a:effectLst/>
-        </p:spPr>
-        <p:style>
-          <a:lnRef idx="1">
-            <a:schemeClr val="accent1"/>
-          </a:lnRef>
-          <a:fillRef idx="3">
-            <a:schemeClr val="accent1"/>
-          </a:fillRef>
-          <a:effectRef idx="2">
-            <a:schemeClr val="accent1"/>
-          </a:effectRef>
-          <a:fontRef idx="minor">
-            <a:schemeClr val="lt1"/>
-          </a:fontRef>
-        </p:style>
-        <p:txBody>
-          <a:bodyPr rtlCol="0" anchor="ctr" wrap="square"/>
-          <a:lstStyle/>
-          <a:p>
-            <a:pPr algn="ctr">
-              <a:spcAft>
-                <a:spcPts val="400"/>
-              </a:spcAft>
-            </a:pPr>
-            <a:r>
-              <a:rPr sz="1600" b="1" i="0">
-                <a:solidFill>
-                  <a:srgbClr val="56686C"/>
-                </a:solidFill>
-                <a:latin typeface="Arial"/>
-              </a:rPr>
-              <a:t>Cole aqui o print</a:t>
-            </a:r>
-          </a:p>
-          <a:p>
-            <a:pPr algn="ctr">
-              <a:spcAft>
-                <a:spcPts val="400"/>
-              </a:spcAft>
-            </a:pPr>
-            <a:r>
-              <a:rPr sz="1400" b="0" i="0">
-                <a:solidFill>
-                  <a:srgbClr val="E8572A"/>
-                </a:solidFill>
-                <a:latin typeface="Courier New"/>
-              </a:rPr>
-              <a:t>05-ghcr-imagem.png</a:t>
-            </a:r>
-          </a:p>
-        </p:txBody>
-      </p:sp>
+        </p:spPr>
+      </p:pic>
       <p:sp>
         <p:nvSpPr>
           <p:cNvPr id="7" name="TextBox 6"/>
@@ -14175,84 +13734,35 @@
           </a:p>
         </p:txBody>
       </p:sp>
-      <p:sp>
-        <p:nvSpPr>
-          <p:cNvPr id="4" name="Espaço para 02-pipeline-develop.png"/>
-          <p:cNvSpPr/>
-          <p:nvPr/>
-        </p:nvSpPr>
-        <p:spPr>
-          <a:xfrm>
-            <a:off x="548640" y="1463040"/>
-            <a:ext cx="5394960" cy="4297680"/>
-          </a:xfrm>
-          <a:prstGeom prst="roundRect">
-            <a:avLst>
-              <a:gd name="adj" fmla="val 2127"/>
-            </a:avLst>
-          </a:prstGeom>
-          <a:solidFill>
-            <a:srgbClr val="F5F8F8"/>
-          </a:solidFill>
-          <a:ln w="15875">
+      <p:pic>
+        <p:nvPicPr>
+          <p:cNvPr id="4" name="Picture 3" descr="02-pipeline-develop.png"/>
+          <p:cNvPicPr>
+            <a:picLocks noChangeAspect="1"/>
+          </p:cNvPicPr>
+          <p:nvPr/>
+        </p:nvPicPr>
+        <p:blipFill>
+          <a:blip r:embed="rId2"/>
+          <a:stretch>
+            <a:fillRect/>
+          </a:stretch>
+        </p:blipFill>
+        <p:spPr>
+          <a:xfrm>
+            <a:off x="548640" y="1811312"/>
+            <a:ext cx="5394960" cy="3601135"/>
+          </a:xfrm>
+          <a:prstGeom prst="rect">
+            <a:avLst/>
+          </a:prstGeom>
+          <a:ln w="9525">
             <a:solidFill>
-              <a:srgbClr val="9AAEB1"/>
+              <a:srgbClr val="C9D9D6"/>
             </a:solidFill>
-            <a:prstDash val="dash"/>
           </a:ln>
-          <a:effectLst/>
-        </p:spPr>
-        <p:style>
-          <a:lnRef idx="1">
-            <a:schemeClr val="accent1"/>
-          </a:lnRef>
-          <a:fillRef idx="3">
-            <a:schemeClr val="accent1"/>
-          </a:fillRef>
-          <a:effectRef idx="2">
-            <a:schemeClr val="accent1"/>
-          </a:effectRef>
-          <a:fontRef idx="minor">
-            <a:schemeClr val="lt1"/>
-          </a:fontRef>
-        </p:style>
-        <p:txBody>
-          <a:bodyPr rtlCol="0" anchor="ctr" wrap="square"/>
-          <a:lstStyle/>
-          <a:p>
-            <a:pPr algn="ctr">
-              <a:spcAft>
-                <a:spcPts val="400"/>
-              </a:spcAft>
-            </a:pPr>
-            <a:r>
-              <a:rPr sz="1600" b="1" i="0">
-                <a:solidFill>
-                  <a:srgbClr val="56686C"/>
-                </a:solidFill>
-                <a:latin typeface="Arial"/>
-              </a:rPr>
-              <a:t>Cole aqui o print</a:t>
-            </a:r>
-          </a:p>
-          <a:p>
-            <a:pPr algn="ctr">
-              <a:spcAft>
-                <a:spcPts val="400"/>
-              </a:spcAft>
-            </a:pPr>
-            <a:r>
-              <a:rPr sz="1400" b="0" i="0">
-                <a:solidFill>
-                  <a:srgbClr val="E8572A"/>
-                </a:solidFill>
-                <a:latin typeface="Courier New"/>
-              </a:rPr>
-              <a:t>02-pipeline-develop.png</a:t>
-            </a:r>
-          </a:p>
-        </p:txBody>
-      </p:sp>
+        </p:spPr>
+      </p:pic>
       <p:sp>
         <p:nvSpPr>
           <p:cNvPr id="5" name="TextBox 4"/>

</xml_diff>

<commit_message>
docs: completa os 14 prints de evidência (testes, compose, main e Supabase)
Co-Authored-By: Claude Opus 5.5 <noreply@anthropic.com>
</commit_message>
<xml_diff>
--- a/docs/Documentacao_DevOps.pptx
+++ b/docs/Documentacao_DevOps.pptx
@@ -4609,84 +4609,35 @@
           </a:p>
         </p:txBody>
       </p:sp>
-      <p:sp>
-        <p:nvSpPr>
-          <p:cNvPr id="6" name="Espaço para 14-supabase.png"/>
-          <p:cNvSpPr/>
-          <p:nvPr/>
-        </p:nvSpPr>
-        <p:spPr>
-          <a:xfrm>
-            <a:off x="6217920" y="1463040"/>
-            <a:ext cx="5394960" cy="4297680"/>
-          </a:xfrm>
-          <a:prstGeom prst="roundRect">
-            <a:avLst>
-              <a:gd name="adj" fmla="val 2127"/>
-            </a:avLst>
-          </a:prstGeom>
-          <a:solidFill>
-            <a:srgbClr val="F5F8F8"/>
-          </a:solidFill>
-          <a:ln w="15875">
+      <p:pic>
+        <p:nvPicPr>
+          <p:cNvPr id="6" name="Picture 5" descr="14-supabase.png"/>
+          <p:cNvPicPr>
+            <a:picLocks noChangeAspect="1"/>
+          </p:cNvPicPr>
+          <p:nvPr/>
+        </p:nvPicPr>
+        <p:blipFill>
+          <a:blip r:embed="rId3"/>
+          <a:stretch>
+            <a:fillRect/>
+          </a:stretch>
+        </p:blipFill>
+        <p:spPr>
+          <a:xfrm>
+            <a:off x="6217920" y="1976876"/>
+            <a:ext cx="5394960" cy="3270006"/>
+          </a:xfrm>
+          <a:prstGeom prst="rect">
+            <a:avLst/>
+          </a:prstGeom>
+          <a:ln w="9525">
             <a:solidFill>
-              <a:srgbClr val="9AAEB1"/>
+              <a:srgbClr val="C9D9D6"/>
             </a:solidFill>
-            <a:prstDash val="dash"/>
           </a:ln>
-          <a:effectLst/>
-        </p:spPr>
-        <p:style>
-          <a:lnRef idx="1">
-            <a:schemeClr val="accent1"/>
-          </a:lnRef>
-          <a:fillRef idx="3">
-            <a:schemeClr val="accent1"/>
-          </a:fillRef>
-          <a:effectRef idx="2">
-            <a:schemeClr val="accent1"/>
-          </a:effectRef>
-          <a:fontRef idx="minor">
-            <a:schemeClr val="lt1"/>
-          </a:fontRef>
-        </p:style>
-        <p:txBody>
-          <a:bodyPr rtlCol="0" anchor="ctr" wrap="square"/>
-          <a:lstStyle/>
-          <a:p>
-            <a:pPr algn="ctr">
-              <a:spcAft>
-                <a:spcPts val="400"/>
-              </a:spcAft>
-            </a:pPr>
-            <a:r>
-              <a:rPr sz="1600" b="1" i="0">
-                <a:solidFill>
-                  <a:srgbClr val="56686C"/>
-                </a:solidFill>
-                <a:latin typeface="Arial"/>
-              </a:rPr>
-              <a:t>Cole aqui o print</a:t>
-            </a:r>
-          </a:p>
-          <a:p>
-            <a:pPr algn="ctr">
-              <a:spcAft>
-                <a:spcPts val="400"/>
-              </a:spcAft>
-            </a:pPr>
-            <a:r>
-              <a:rPr sz="1400" b="0" i="0">
-                <a:solidFill>
-                  <a:srgbClr val="E8572A"/>
-                </a:solidFill>
-                <a:latin typeface="Courier New"/>
-              </a:rPr>
-              <a:t>14-supabase.png</a:t>
-            </a:r>
-          </a:p>
-        </p:txBody>
-      </p:sp>
+        </p:spPr>
+      </p:pic>
       <p:sp>
         <p:nvSpPr>
           <p:cNvPr id="7" name="TextBox 6"/>
@@ -6505,11 +6456,11 @@
                       <a:r>
                         <a:rPr sz="1400" b="1" i="0">
                           <a:solidFill>
-                            <a:srgbClr val="E8572A"/>
+                            <a:srgbClr val="2E7D4F"/>
                           </a:solidFill>
                           <a:latin typeface="Arial"/>
                         </a:rPr>
-                        <a:t>Pendente</a:t>
+                        <a:t>Concluído</a:t>
                       </a:r>
                     </a:p>
                   </a:txBody>
@@ -6588,11 +6539,11 @@
                       <a:r>
                         <a:rPr sz="1400" b="1" i="0">
                           <a:solidFill>
-                            <a:srgbClr val="E8572A"/>
+                            <a:srgbClr val="2E7D4F"/>
                           </a:solidFill>
                           <a:latin typeface="Arial"/>
                         </a:rPr>
-                        <a:t>Pendente</a:t>
+                        <a:t>Concluído</a:t>
                       </a:r>
                     </a:p>
                   </a:txBody>
@@ -13090,84 +13041,35 @@
           </a:p>
         </p:txBody>
       </p:sp>
-      <p:sp>
-        <p:nvSpPr>
-          <p:cNvPr id="6" name="Espaço para 03-testes-resumo.png"/>
-          <p:cNvSpPr/>
-          <p:nvPr/>
-        </p:nvSpPr>
-        <p:spPr>
-          <a:xfrm>
-            <a:off x="6217920" y="1463040"/>
-            <a:ext cx="5394960" cy="4297680"/>
-          </a:xfrm>
-          <a:prstGeom prst="roundRect">
-            <a:avLst>
-              <a:gd name="adj" fmla="val 2127"/>
-            </a:avLst>
-          </a:prstGeom>
-          <a:solidFill>
-            <a:srgbClr val="F5F8F8"/>
-          </a:solidFill>
-          <a:ln w="15875">
+      <p:pic>
+        <p:nvPicPr>
+          <p:cNvPr id="6" name="Picture 5" descr="03-testes-resumo.png"/>
+          <p:cNvPicPr>
+            <a:picLocks noChangeAspect="1"/>
+          </p:cNvPicPr>
+          <p:nvPr/>
+        </p:nvPicPr>
+        <p:blipFill>
+          <a:blip r:embed="rId3"/>
+          <a:stretch>
+            <a:fillRect/>
+          </a:stretch>
+        </p:blipFill>
+        <p:spPr>
+          <a:xfrm>
+            <a:off x="6217920" y="2215934"/>
+            <a:ext cx="5394960" cy="2791891"/>
+          </a:xfrm>
+          <a:prstGeom prst="rect">
+            <a:avLst/>
+          </a:prstGeom>
+          <a:ln w="9525">
             <a:solidFill>
-              <a:srgbClr val="9AAEB1"/>
+              <a:srgbClr val="C9D9D6"/>
             </a:solidFill>
-            <a:prstDash val="dash"/>
           </a:ln>
-          <a:effectLst/>
-        </p:spPr>
-        <p:style>
-          <a:lnRef idx="1">
-            <a:schemeClr val="accent1"/>
-          </a:lnRef>
-          <a:fillRef idx="3">
-            <a:schemeClr val="accent1"/>
-          </a:fillRef>
-          <a:effectRef idx="2">
-            <a:schemeClr val="accent1"/>
-          </a:effectRef>
-          <a:fontRef idx="minor">
-            <a:schemeClr val="lt1"/>
-          </a:fontRef>
-        </p:style>
-        <p:txBody>
-          <a:bodyPr rtlCol="0" anchor="ctr" wrap="square"/>
-          <a:lstStyle/>
-          <a:p>
-            <a:pPr algn="ctr">
-              <a:spcAft>
-                <a:spcPts val="400"/>
-              </a:spcAft>
-            </a:pPr>
-            <a:r>
-              <a:rPr sz="1600" b="1" i="0">
-                <a:solidFill>
-                  <a:srgbClr val="56686C"/>
-                </a:solidFill>
-                <a:latin typeface="Arial"/>
-              </a:rPr>
-              <a:t>Cole aqui o print</a:t>
-            </a:r>
-          </a:p>
-          <a:p>
-            <a:pPr algn="ctr">
-              <a:spcAft>
-                <a:spcPts val="400"/>
-              </a:spcAft>
-            </a:pPr>
-            <a:r>
-              <a:rPr sz="1400" b="0" i="0">
-                <a:solidFill>
-                  <a:srgbClr val="E8572A"/>
-                </a:solidFill>
-                <a:latin typeface="Courier New"/>
-              </a:rPr>
-              <a:t>03-testes-resumo.png</a:t>
-            </a:r>
-          </a:p>
-        </p:txBody>
-      </p:sp>
+        </p:spPr>
+      </p:pic>
       <p:sp>
         <p:nvSpPr>
           <p:cNvPr id="7" name="TextBox 6"/>
@@ -13379,84 +13281,35 @@
           </a:p>
         </p:txBody>
       </p:sp>
-      <p:sp>
-        <p:nvSpPr>
-          <p:cNvPr id="4" name="Espaço para 04-compose-smoke.png"/>
-          <p:cNvSpPr/>
-          <p:nvPr/>
-        </p:nvSpPr>
-        <p:spPr>
-          <a:xfrm>
-            <a:off x="548640" y="1463040"/>
-            <a:ext cx="5394960" cy="4297680"/>
-          </a:xfrm>
-          <a:prstGeom prst="roundRect">
-            <a:avLst>
-              <a:gd name="adj" fmla="val 2127"/>
-            </a:avLst>
-          </a:prstGeom>
-          <a:solidFill>
-            <a:srgbClr val="F5F8F8"/>
-          </a:solidFill>
-          <a:ln w="15875">
+      <p:pic>
+        <p:nvPicPr>
+          <p:cNvPr id="4" name="Picture 3" descr="04-compose-smoke.png"/>
+          <p:cNvPicPr>
+            <a:picLocks noChangeAspect="1"/>
+          </p:cNvPicPr>
+          <p:nvPr/>
+        </p:nvPicPr>
+        <p:blipFill>
+          <a:blip r:embed="rId2"/>
+          <a:stretch>
+            <a:fillRect/>
+          </a:stretch>
+        </p:blipFill>
+        <p:spPr>
+          <a:xfrm>
+            <a:off x="548640" y="2030482"/>
+            <a:ext cx="5394960" cy="3162795"/>
+          </a:xfrm>
+          <a:prstGeom prst="rect">
+            <a:avLst/>
+          </a:prstGeom>
+          <a:ln w="9525">
             <a:solidFill>
-              <a:srgbClr val="9AAEB1"/>
+              <a:srgbClr val="C9D9D6"/>
             </a:solidFill>
-            <a:prstDash val="dash"/>
           </a:ln>
-          <a:effectLst/>
-        </p:spPr>
-        <p:style>
-          <a:lnRef idx="1">
-            <a:schemeClr val="accent1"/>
-          </a:lnRef>
-          <a:fillRef idx="3">
-            <a:schemeClr val="accent1"/>
-          </a:fillRef>
-          <a:effectRef idx="2">
-            <a:schemeClr val="accent1"/>
-          </a:effectRef>
-          <a:fontRef idx="minor">
-            <a:schemeClr val="lt1"/>
-          </a:fontRef>
-        </p:style>
-        <p:txBody>
-          <a:bodyPr rtlCol="0" anchor="ctr" wrap="square"/>
-          <a:lstStyle/>
-          <a:p>
-            <a:pPr algn="ctr">
-              <a:spcAft>
-                <a:spcPts val="400"/>
-              </a:spcAft>
-            </a:pPr>
-            <a:r>
-              <a:rPr sz="1600" b="1" i="0">
-                <a:solidFill>
-                  <a:srgbClr val="56686C"/>
-                </a:solidFill>
-                <a:latin typeface="Arial"/>
-              </a:rPr>
-              <a:t>Cole aqui o print</a:t>
-            </a:r>
-          </a:p>
-          <a:p>
-            <a:pPr algn="ctr">
-              <a:spcAft>
-                <a:spcPts val="400"/>
-              </a:spcAft>
-            </a:pPr>
-            <a:r>
-              <a:rPr sz="1400" b="0" i="0">
-                <a:solidFill>
-                  <a:srgbClr val="E8572A"/>
-                </a:solidFill>
-                <a:latin typeface="Courier New"/>
-              </a:rPr>
-              <a:t>04-compose-smoke.png</a:t>
-            </a:r>
-          </a:p>
-        </p:txBody>
-      </p:sp>
+        </p:spPr>
+      </p:pic>
       <p:sp>
         <p:nvSpPr>
           <p:cNvPr id="5" name="TextBox 4"/>
@@ -13503,7 +13356,7 @@
           <p:nvPr/>
         </p:nvPicPr>
         <p:blipFill>
-          <a:blip r:embed="rId2"/>
+          <a:blip r:embed="rId3"/>
           <a:stretch>
             <a:fillRect/>
           </a:stretch>
@@ -13800,84 +13653,35 @@
           </a:p>
         </p:txBody>
       </p:sp>
-      <p:sp>
-        <p:nvSpPr>
-          <p:cNvPr id="6" name="Espaço para 07-pipeline-main.png"/>
-          <p:cNvSpPr/>
-          <p:nvPr/>
-        </p:nvSpPr>
-        <p:spPr>
-          <a:xfrm>
-            <a:off x="6217920" y="1463040"/>
-            <a:ext cx="5394960" cy="4297680"/>
-          </a:xfrm>
-          <a:prstGeom prst="roundRect">
-            <a:avLst>
-              <a:gd name="adj" fmla="val 2127"/>
-            </a:avLst>
-          </a:prstGeom>
-          <a:solidFill>
-            <a:srgbClr val="F5F8F8"/>
-          </a:solidFill>
-          <a:ln w="15875">
+      <p:pic>
+        <p:nvPicPr>
+          <p:cNvPr id="6" name="Picture 5" descr="07-pipeline-main.png"/>
+          <p:cNvPicPr>
+            <a:picLocks noChangeAspect="1"/>
+          </p:cNvPicPr>
+          <p:nvPr/>
+        </p:nvPicPr>
+        <p:blipFill>
+          <a:blip r:embed="rId3"/>
+          <a:stretch>
+            <a:fillRect/>
+          </a:stretch>
+        </p:blipFill>
+        <p:spPr>
+          <a:xfrm>
+            <a:off x="6217920" y="1976532"/>
+            <a:ext cx="5394960" cy="3270694"/>
+          </a:xfrm>
+          <a:prstGeom prst="rect">
+            <a:avLst/>
+          </a:prstGeom>
+          <a:ln w="9525">
             <a:solidFill>
-              <a:srgbClr val="9AAEB1"/>
+              <a:srgbClr val="C9D9D6"/>
             </a:solidFill>
-            <a:prstDash val="dash"/>
           </a:ln>
-          <a:effectLst/>
-        </p:spPr>
-        <p:style>
-          <a:lnRef idx="1">
-            <a:schemeClr val="accent1"/>
-          </a:lnRef>
-          <a:fillRef idx="3">
-            <a:schemeClr val="accent1"/>
-          </a:fillRef>
-          <a:effectRef idx="2">
-            <a:schemeClr val="accent1"/>
-          </a:effectRef>
-          <a:fontRef idx="minor">
-            <a:schemeClr val="lt1"/>
-          </a:fontRef>
-        </p:style>
-        <p:txBody>
-          <a:bodyPr rtlCol="0" anchor="ctr" wrap="square"/>
-          <a:lstStyle/>
-          <a:p>
-            <a:pPr algn="ctr">
-              <a:spcAft>
-                <a:spcPts val="400"/>
-              </a:spcAft>
-            </a:pPr>
-            <a:r>
-              <a:rPr sz="1600" b="1" i="0">
-                <a:solidFill>
-                  <a:srgbClr val="56686C"/>
-                </a:solidFill>
-                <a:latin typeface="Arial"/>
-              </a:rPr>
-              <a:t>Cole aqui o print</a:t>
-            </a:r>
-          </a:p>
-          <a:p>
-            <a:pPr algn="ctr">
-              <a:spcAft>
-                <a:spcPts val="400"/>
-              </a:spcAft>
-            </a:pPr>
-            <a:r>
-              <a:rPr sz="1400" b="0" i="0">
-                <a:solidFill>
-                  <a:srgbClr val="E8572A"/>
-                </a:solidFill>
-                <a:latin typeface="Courier New"/>
-              </a:rPr>
-              <a:t>07-pipeline-main.png</a:t>
-            </a:r>
-          </a:p>
-        </p:txBody>
-      </p:sp>
+        </p:spPr>
+      </p:pic>
       <p:sp>
         <p:nvSpPr>
           <p:cNvPr id="7" name="TextBox 6"/>

</xml_diff>